<commit_message>
Honest XGB vs LSTM slides; drive live brain from real model output
Wire the live panel to a NumPy replay of baseline_univariate.keras on the
closest Metro Interstate test hour (sidecar + static lookup). Slides and
PPTX now say XGBoost won on motorway MAE, LSTM won narrowly on bikes, and
the intersection is simulation-only — not a closed-loop controller.

Co-authored-by: xxraphaelgirardxx <xxraphaelgirardxx@gmail.com>
</commit_message>
<xml_diff>
--- a/presentation/Traffic_LSTM_Presentation.pptx
+++ b/presentation/Traffic_LSTM_Presentation.pptx
@@ -4894,7 +4894,7 @@
                 </a:solidFill>
                 <a:latin typeface="Calibri"/>
               </a:rPr>
-              <a:t>live LSTM gates (forget / input / output), a neural graph that lights up, and a step-by-step decision trace: sense queue → update memory → forecast → stretch green.</a:t>
+              <a:t>gates and neurons from a real Keras-weight replay of the closest Metro Interstate hour — not a quiet/rush blend, not closed-loop control.</a:t>
             </a:r>
           </a:p>
           <a:p>
@@ -4922,7 +4922,7 @@
                 </a:solidFill>
                 <a:latin typeface="Calibri"/>
               </a:rPr>
-              <a:t>green time follows queue pressure — 4 s minimum up to 16 s under a jam.</a:t>
+              <a:t>heuristic from queue/forecast — the LSTM did not choose the light. 4 s minimum up to 16 s under a jam.</a:t>
             </a:r>
           </a:p>
         </p:txBody>
@@ -4961,7 +4961,7 @@
                 </a:solidFill>
                 <a:latin typeface="Calibri"/>
               </a:rPr>
-              <a:t>Simulation only — no connection to real signals or city sensors</a:t>
+              <a:t>Simulation only — cartoon lights are not a closed-loop controller and are not connected to city signals</a:t>
             </a:r>
           </a:p>
         </p:txBody>
@@ -5199,7 +5199,7 @@
                 </a:solidFill>
                 <a:latin typeface="Calibri"/>
               </a:rPr>
-              <a:t>the output is a number a controller could consume — this project never touches signal hardware.</a:t>
+              <a:t>the cartoon lights are not a closed-loop controller. This project never touches signal hardware.</a:t>
             </a:r>
           </a:p>
           <a:p>
@@ -5553,7 +5553,7 @@
                 </a:solidFill>
                 <a:latin typeface="Calibri"/>
               </a:rPr>
-              <a:t>▸ Stacked LSTM, 24 hours → next-hour vehicles, 61–66% better than naive rules.</a:t>
+              <a:t>▸ Stacked LSTM vs XGBoost: motorway MAE 154.3 (XGB) vs 201.4 (LSTM); bikes 41.3 vs 43.1 — verdict flips.</a:t>
             </a:r>
           </a:p>
           <a:p>
@@ -5610,7 +5610,7 @@
                 </a:solidFill>
                 <a:latin typeface="Calibri"/>
               </a:rPr>
-              <a:t>▸ Live demo: an intersection that obeys real traffic rules while the network's thinking stays on screen.</a:t>
+              <a:t>▸ Live demo: simulation only; real Keras-hour replay in the brain; heuristic greens — not city signals.</a:t>
             </a:r>
           </a:p>
         </p:txBody>
@@ -6119,7 +6119,7 @@
                 </a:solidFill>
                 <a:latin typeface="Consolas"/>
               </a:rPr>
-              <a:t>02 · WHY LSTM IS THE RIGHT ALGORITHM HERE</a:t>
+              <a:t>02 · WHY LSTM WAS STILL STUDIED</a:t>
             </a:r>
           </a:p>
         </p:txBody>
@@ -6158,7 +6158,7 @@
                 </a:solidFill>
                 <a:latin typeface="Georgia"/>
               </a:rPr>
-              <a:t>Traffic has memory. LSTM is built for memory.</a:t>
+              <a:t>Sequential hours, gates, inspectable state.</a:t>
             </a:r>
           </a:p>
         </p:txBody>
@@ -6200,7 +6200,7 @@
                 </a:solidFill>
                 <a:latin typeface="Calibri"/>
               </a:rPr>
-              <a:t>▸ Ordered dependence — </a:t>
+              <a:t>▸ Not the blanket winner — </a:t>
             </a:r>
             <a:r>
               <a:rPr sz="1550">
@@ -6209,7 +6209,7 @@
                 </a:solidFill>
                 <a:latin typeface="Calibri"/>
               </a:rPr>
-              <a:t>rush hour builds over hours — 8h ago still matters. A feed-forward net sees a flat vector; an LSTM carries a cell state through the sequence and decides what to keep.</a:t>
+              <a:t>XGBoost+calendar MAE 154.3 beat LSTM+calendar 201.4 on Metro Interstate. We did not study LSTM because it is “the right algorithm”.</a:t>
             </a:r>
           </a:p>
           <a:p>
@@ -6228,7 +6228,7 @@
                 </a:solidFill>
                 <a:latin typeface="Calibri"/>
               </a:rPr>
-              <a:t>▸ Selective memory is inspectable — </a:t>
+              <a:t>▸ Ordered dependence — </a:t>
             </a:r>
             <a:r>
               <a:rPr sz="1550">
@@ -6237,7 +6237,7 @@
                 </a:solidFill>
                 <a:latin typeface="Calibri"/>
               </a:rPr>
-              <a:t>forget / input / output gates are explicit multiplicative valves. We can read them — and this project does, neuron by neuron.</a:t>
+              <a:t>rush hour builds over hours. A cell state walks the sequence and decides what to keep — that mechanism is the reason to open the box.</a:t>
             </a:r>
           </a:p>
           <a:p>
@@ -6256,7 +6256,7 @@
                 </a:solidFill>
                 <a:latin typeface="Calibri"/>
               </a:rPr>
-              <a:t>▸ Long-range without explosion — </a:t>
+              <a:t>▸ Selective memory is inspectable — </a:t>
             </a:r>
             <a:r>
               <a:rPr sz="1550">
@@ -6265,7 +6265,7 @@
                 </a:solidFill>
                 <a:latin typeface="Calibri"/>
               </a:rPr>
-              <a:t>the cell state's additive update (c = f·c + i·g) avoids the vanishing gradient that kills plain RNNs on 24-step sequences.</a:t>
+              <a:t>forget / input / output gates are explicit valves. introspect.py replays them from trained weights, checked against Keras to ~1e-7.</a:t>
             </a:r>
           </a:p>
           <a:p>
@@ -6284,7 +6284,7 @@
                 </a:solidFill>
                 <a:latin typeface="Calibri"/>
               </a:rPr>
-              <a:t>▸ Multivariate &amp; multi-horizon ready — </a:t>
+              <a:t>▸ The live panel is inspection — </a:t>
             </a:r>
             <a:r>
               <a:rPr sz="1550">
@@ -6293,35 +6293,7 @@
                 </a:solidFill>
                 <a:latin typeface="Calibri"/>
               </a:rPr>
-              <a:t>weather, calendar, and horizons 1/3/6 drop in as extra channels — no feature re-engineering.</a:t>
-            </a:r>
-          </a:p>
-          <a:p>
-            <a:pPr>
-              <a:lnSpc>
-                <a:spcPct val="112000"/>
-              </a:lnSpc>
-              <a:spcAft>
-                <a:spcPts val="1100"/>
-              </a:spcAft>
-            </a:pPr>
-            <a:r>
-              <a:rPr b="1" sz="1550">
-                <a:solidFill>
-                  <a:srgbClr val="2EC4B6"/>
-                </a:solidFill>
-                <a:latin typeface="Calibri"/>
-              </a:rPr>
-              <a:t>▸ Proven on this data — </a:t>
-            </a:r>
-            <a:r>
-              <a:rPr sz="1550">
-                <a:solidFill>
-                  <a:srgbClr val="F4EFE6"/>
-                </a:solidFill>
-                <a:latin typeface="Calibri"/>
-              </a:rPr>
-              <a:t>beats both naive baselines by ~61% and wins outright on the second dataset (bike sharing).</a:t>
+              <a:t>nearest real test hour, then a real forward pass. It is not proof that an LSTM should run a city’s lights.</a:t>
             </a:r>
           </a:p>
         </p:txBody>
@@ -6360,7 +6332,7 @@
                 </a:solidFill>
                 <a:latin typeface="Calibri"/>
               </a:rPr>
-              <a:t>Hochreiter &amp; Schmidhuber, 1997 — applied to hourly traffic counts</a:t>
+              <a:t>Hochreiter &amp; Schmidhuber, 1997 — used here as an inspectable sequence model, not as a championship claim</a:t>
             </a:r>
           </a:p>
         </p:txBody>
@@ -6953,7 +6925,7 @@
                 </a:solidFill>
                 <a:latin typeface="Calibri"/>
               </a:rPr>
-              <a:t>Engineering stance: XGBoost is the champion baseline; the LSTM is the challenger that explains itself.</a:t>
+              <a:t>Say this out loud: XGBoost won on motorway MAE (154.3 vs LSTM 201.4). LSTM won narrowly on bikes</a:t>
             </a:r>
           </a:p>
           <a:p>
@@ -6969,7 +6941,7 @@
                 </a:solidFill>
                 <a:latin typeface="Calibri"/>
               </a:rPr>
-              <a:t>Where temporal structure dominates (bike rentals), the LSTM wins. The tool choice is empirical — measured, not argued.</a:t>
+              <a:t>(41.3 vs 43.1 univariate; 38.5 vs 38.6 with weather+calendar). The verdict flips. Keep both.</a:t>
             </a:r>
           </a:p>
         </p:txBody>
@@ -10625,7 +10597,7 @@
                 </a:solidFill>
                 <a:latin typeface="Consolas"/>
               </a:rPr>
-              <a:t>08 · THE VERDICT FLIPS</a:t>
+              <a:t>08 · THE VERDICT FLIPS — SAY IT OUT LOUD</a:t>
             </a:r>
           </a:p>
         </p:txBody>
@@ -10664,7 +10636,7 @@
                 </a:solidFill>
                 <a:latin typeface="Georgia"/>
               </a:rPr>
-              <a:t>Second dataset, opposite winner.</a:t>
+              <a:t>XGBoost won on motorway. LSTM won on bikes.</a:t>
             </a:r>
           </a:p>
         </p:txBody>
@@ -11041,7 +11013,7 @@
                 </a:solidFill>
                 <a:latin typeface="Calibri"/>
               </a:rPr>
-              <a:t>one dataset cannot settle “LSTM vs boosting” — the question is empirical, and this project measures it instead of asserting it.</a:t>
+              <a:t>one dataset cannot settle “LSTM vs boosting”. Verdict flips. That is why both stay.</a:t>
             </a:r>
           </a:p>
         </p:txBody>

</xml_diff>